<commit_message>
Update webscrapingproject main File.pptx
</commit_message>
<xml_diff>
--- a/webscrapingproject main File.pptx
+++ b/webscrapingproject main File.pptx
@@ -5,51 +5,52 @@
     <p:sldMasterId id="2147483648" r:id="rId1"/>
   </p:sldMasterIdLst>
   <p:notesMasterIdLst>
-    <p:notesMasterId r:id="rId23"/>
+    <p:notesMasterId r:id="rId24"/>
   </p:notesMasterIdLst>
   <p:sldIdLst>
     <p:sldId id="256" r:id="rId2"/>
     <p:sldId id="257" r:id="rId3"/>
     <p:sldId id="260" r:id="rId4"/>
     <p:sldId id="261" r:id="rId5"/>
-    <p:sldId id="263" r:id="rId6"/>
-    <p:sldId id="264" r:id="rId7"/>
-    <p:sldId id="281" r:id="rId8"/>
-    <p:sldId id="265" r:id="rId9"/>
-    <p:sldId id="271" r:id="rId10"/>
-    <p:sldId id="272" r:id="rId11"/>
-    <p:sldId id="273" r:id="rId12"/>
-    <p:sldId id="274" r:id="rId13"/>
-    <p:sldId id="275" r:id="rId14"/>
-    <p:sldId id="276" r:id="rId15"/>
-    <p:sldId id="262" r:id="rId16"/>
-    <p:sldId id="278" r:id="rId17"/>
-    <p:sldId id="279" r:id="rId18"/>
-    <p:sldId id="267" r:id="rId19"/>
-    <p:sldId id="268" r:id="rId20"/>
-    <p:sldId id="270" r:id="rId21"/>
-    <p:sldId id="259" r:id="rId22"/>
+    <p:sldId id="282" r:id="rId6"/>
+    <p:sldId id="263" r:id="rId7"/>
+    <p:sldId id="264" r:id="rId8"/>
+    <p:sldId id="281" r:id="rId9"/>
+    <p:sldId id="265" r:id="rId10"/>
+    <p:sldId id="271" r:id="rId11"/>
+    <p:sldId id="272" r:id="rId12"/>
+    <p:sldId id="273" r:id="rId13"/>
+    <p:sldId id="274" r:id="rId14"/>
+    <p:sldId id="275" r:id="rId15"/>
+    <p:sldId id="276" r:id="rId16"/>
+    <p:sldId id="262" r:id="rId17"/>
+    <p:sldId id="278" r:id="rId18"/>
+    <p:sldId id="279" r:id="rId19"/>
+    <p:sldId id="267" r:id="rId20"/>
+    <p:sldId id="268" r:id="rId21"/>
+    <p:sldId id="270" r:id="rId22"/>
+    <p:sldId id="259" r:id="rId23"/>
   </p:sldIdLst>
   <p:sldSz cx="12192000" cy="6858000"/>
   <p:notesSz cx="6858000" cy="9144000"/>
   <p:embeddedFontLst>
     <p:embeddedFont>
       <p:font typeface="Consolas" panose="020B0609020204030204" pitchFamily="49" charset="0"/>
-      <p:regular r:id="rId24"/>
-      <p:bold r:id="rId25"/>
-      <p:italic r:id="rId26"/>
-      <p:boldItalic r:id="rId27"/>
+      <p:regular r:id="rId25"/>
+      <p:bold r:id="rId26"/>
+      <p:italic r:id="rId27"/>
+      <p:boldItalic r:id="rId28"/>
     </p:embeddedFont>
     <p:embeddedFont>
       <p:font typeface="Lato Black" panose="020F0502020204030203" pitchFamily="34" charset="0"/>
-      <p:bold r:id="rId28"/>
-      <p:boldItalic r:id="rId29"/>
+      <p:bold r:id="rId29"/>
+      <p:boldItalic r:id="rId30"/>
     </p:embeddedFont>
     <p:embeddedFont>
       <p:font typeface="Libre Baskerville" panose="02000000000000000000" pitchFamily="2" charset="0"/>
-      <p:regular r:id="rId30"/>
-      <p:bold r:id="rId31"/>
-      <p:italic r:id="rId32"/>
+      <p:regular r:id="rId31"/>
+      <p:bold r:id="rId32"/>
+      <p:italic r:id="rId33"/>
     </p:embeddedFont>
   </p:embeddedFontLst>
   <p:defaultTextStyle>
@@ -286,7 +287,7 @@
       <p15:sldGuideLst xmlns:p15="http://schemas.microsoft.com/office/powerpoint/2012/main"/>
     </p:ext>
     <p:ext uri="GoogleSlidesCustomDataVersion2">
-      <go:slidesCustomData xmlns="" xmlns:mc="http://schemas.openxmlformats.org/markup-compatibility/2006" xmlns:mv="urn:schemas-microsoft-com:mac:vml" xmlns:c="http://schemas.openxmlformats.org/drawingml/2006/chart" xmlns:dgm="http://schemas.openxmlformats.org/drawingml/2006/diagram" xmlns:o="urn:schemas-microsoft-com:office:office" xmlns:v="urn:schemas-microsoft-com:vml" xmlns:pvml="urn:schemas-microsoft-com:office:powerpoint" xmlns:com="http://schemas.openxmlformats.org/drawingml/2006/compatibility" xmlns:p14="http://schemas.microsoft.com/office/powerpoint/2010/main" xmlns:p15="http://schemas.microsoft.com/office/powerpoint/2012/main" xmlns:ahyp="http://schemas.microsoft.com/office/drawing/2018/hyperlinkcolor" xmlns:go="http://customooxmlschemas.google.com/" r:id="rId35" roundtripDataSignature="AMtx7mhnFQsu0qTBRZ+C47HNp0tuHCNkog=="/>
+      <go:slidesCustomData xmlns:go="http://customooxmlschemas.google.com/" xmlns:ahyp="http://schemas.microsoft.com/office/drawing/2018/hyperlinkcolor" xmlns:p15="http://schemas.microsoft.com/office/powerpoint/2012/main" xmlns:p14="http://schemas.microsoft.com/office/powerpoint/2010/main" xmlns:com="http://schemas.openxmlformats.org/drawingml/2006/compatibility" xmlns:pvml="urn:schemas-microsoft-com:office:powerpoint" xmlns:v="urn:schemas-microsoft-com:vml" xmlns:o="urn:schemas-microsoft-com:office:office" xmlns:dgm="http://schemas.openxmlformats.org/drawingml/2006/diagram" xmlns:c="http://schemas.openxmlformats.org/drawingml/2006/chart" xmlns:mv="urn:schemas-microsoft-com:mac:vml" xmlns:mc="http://schemas.openxmlformats.org/markup-compatibility/2006" xmlns="" r:id="rId35" roundtripDataSignature="AMtx7mhnFQsu0qTBRZ+C47HNp0tuHCNkog=="/>
     </p:ext>
   </p:extLst>
 </p:presentation>
@@ -11286,6 +11287,114 @@
       </p:grpSpPr>
       <p:pic>
         <p:nvPicPr>
+          <p:cNvPr id="4" name="Picture 3">
+            <a:extLst>
+              <a:ext uri="{FF2B5EF4-FFF2-40B4-BE49-F238E27FC236}">
+                <a16:creationId xmlns:a16="http://schemas.microsoft.com/office/drawing/2014/main" id="{92EF33CE-33B5-55EE-D839-F06634CC2E79}"/>
+              </a:ext>
+            </a:extLst>
+          </p:cNvPr>
+          <p:cNvPicPr>
+            <a:picLocks noChangeAspect="1"/>
+          </p:cNvPicPr>
+          <p:nvPr/>
+        </p:nvPicPr>
+        <p:blipFill>
+          <a:blip r:embed="rId2"/>
+          <a:stretch>
+            <a:fillRect/>
+          </a:stretch>
+        </p:blipFill>
+        <p:spPr>
+          <a:xfrm>
+            <a:off x="0" y="1181484"/>
+            <a:ext cx="12192000" cy="4495031"/>
+          </a:xfrm>
+          <a:prstGeom prst="rect">
+            <a:avLst/>
+          </a:prstGeom>
+        </p:spPr>
+      </p:pic>
+      <p:sp>
+        <p:nvSpPr>
+          <p:cNvPr id="6" name="TextBox 5">
+            <a:extLst>
+              <a:ext uri="{FF2B5EF4-FFF2-40B4-BE49-F238E27FC236}">
+                <a16:creationId xmlns:a16="http://schemas.microsoft.com/office/drawing/2014/main" id="{8FAFE32F-A5A1-6DBF-2190-651C056560F0}"/>
+              </a:ext>
+            </a:extLst>
+          </p:cNvPr>
+          <p:cNvSpPr txBox="1"/>
+          <p:nvPr/>
+        </p:nvSpPr>
+        <p:spPr>
+          <a:xfrm>
+            <a:off x="0" y="338912"/>
+            <a:ext cx="12192000" cy="355418"/>
+          </a:xfrm>
+          <a:prstGeom prst="rect">
+            <a:avLst/>
+          </a:prstGeom>
+          <a:noFill/>
+        </p:spPr>
+        <p:txBody>
+          <a:bodyPr wrap="square">
+            <a:spAutoFit/>
+          </a:bodyPr>
+          <a:lstStyle/>
+          <a:p>
+            <a:pPr algn="ctr">
+              <a:lnSpc>
+                <a:spcPts val="1425"/>
+              </a:lnSpc>
+              <a:buNone/>
+            </a:pPr>
+            <a:r>
+              <a:rPr lang="en-GB" sz="4400" kern="1200" dirty="0">
+                <a:solidFill>
+                  <a:schemeClr val="tx1"/>
+                </a:solidFill>
+                <a:latin typeface="+mj-lt"/>
+                <a:ea typeface="+mj-ea"/>
+                <a:cs typeface="+mj-cs"/>
+              </a:rPr>
+              <a:t>Furnishing Status Analysis</a:t>
+            </a:r>
+          </a:p>
+        </p:txBody>
+      </p:sp>
+    </p:spTree>
+    <p:extLst>
+      <p:ext uri="{BB962C8B-B14F-4D97-AF65-F5344CB8AC3E}">
+        <p14:creationId xmlns:p14="http://schemas.microsoft.com/office/powerpoint/2010/main" val="372715865"/>
+      </p:ext>
+    </p:extLst>
+  </p:cSld>
+  <p:clrMapOvr>
+    <a:masterClrMapping/>
+  </p:clrMapOvr>
+</p:sld>
+</file>
+
+<file path=ppt/slides/slide11.xml><?xml version="1.0" encoding="utf-8"?>
+<p:sld xmlns:a="http://schemas.openxmlformats.org/drawingml/2006/main" xmlns:r="http://schemas.openxmlformats.org/officeDocument/2006/relationships" xmlns:p="http://schemas.openxmlformats.org/presentationml/2006/main">
+  <p:cSld>
+    <p:spTree>
+      <p:nvGrpSpPr>
+        <p:cNvPr id="1" name=""/>
+        <p:cNvGrpSpPr/>
+        <p:nvPr/>
+      </p:nvGrpSpPr>
+      <p:grpSpPr>
+        <a:xfrm>
+          <a:off x="0" y="0"/>
+          <a:ext cx="0" cy="0"/>
+          <a:chOff x="0" y="0"/>
+          <a:chExt cx="0" cy="0"/>
+        </a:xfrm>
+      </p:grpSpPr>
+      <p:pic>
+        <p:nvPicPr>
           <p:cNvPr id="8" name="Picture 7">
             <a:extLst>
               <a:ext uri="{FF2B5EF4-FFF2-40B4-BE49-F238E27FC236}">
@@ -11375,7 +11484,7 @@
 </p:sld>
 </file>
 
-<file path=ppt/slides/slide11.xml><?xml version="1.0" encoding="utf-8"?>
+<file path=ppt/slides/slide12.xml><?xml version="1.0" encoding="utf-8"?>
 <p:sld xmlns:a="http://schemas.openxmlformats.org/drawingml/2006/main" xmlns:r="http://schemas.openxmlformats.org/officeDocument/2006/relationships" xmlns:p="http://schemas.openxmlformats.org/presentationml/2006/main">
   <p:cSld>
     <p:spTree>
@@ -11489,7 +11598,7 @@
 </p:sld>
 </file>
 
-<file path=ppt/slides/slide12.xml><?xml version="1.0" encoding="utf-8"?>
+<file path=ppt/slides/slide13.xml><?xml version="1.0" encoding="utf-8"?>
 <p:sld xmlns:a="http://schemas.openxmlformats.org/drawingml/2006/main" xmlns:r="http://schemas.openxmlformats.org/officeDocument/2006/relationships" xmlns:p="http://schemas.openxmlformats.org/presentationml/2006/main">
   <p:cSld>
     <p:spTree>
@@ -11610,7 +11719,7 @@
 </p:sld>
 </file>
 
-<file path=ppt/slides/slide13.xml><?xml version="1.0" encoding="utf-8"?>
+<file path=ppt/slides/slide14.xml><?xml version="1.0" encoding="utf-8"?>
 <p:sld xmlns:a="http://schemas.openxmlformats.org/drawingml/2006/main" xmlns:r="http://schemas.openxmlformats.org/officeDocument/2006/relationships" xmlns:p="http://schemas.openxmlformats.org/presentationml/2006/main">
   <p:cSld>
     <p:bg>
@@ -11740,7 +11849,7 @@
 </p:sld>
 </file>
 
-<file path=ppt/slides/slide14.xml><?xml version="1.0" encoding="utf-8"?>
+<file path=ppt/slides/slide15.xml><?xml version="1.0" encoding="utf-8"?>
 <p:sld xmlns:a="http://schemas.openxmlformats.org/drawingml/2006/main" xmlns:r="http://schemas.openxmlformats.org/officeDocument/2006/relationships" xmlns:p="http://schemas.openxmlformats.org/presentationml/2006/main">
   <p:cSld>
     <p:bg>
@@ -11880,7 +11989,7 @@
 </p:sld>
 </file>
 
-<file path=ppt/slides/slide15.xml><?xml version="1.0" encoding="utf-8"?>
+<file path=ppt/slides/slide16.xml><?xml version="1.0" encoding="utf-8"?>
 <p:sld xmlns:a="http://schemas.openxmlformats.org/drawingml/2006/main" xmlns:r="http://schemas.openxmlformats.org/officeDocument/2006/relationships" xmlns:p="http://schemas.openxmlformats.org/presentationml/2006/main">
   <p:cSld>
     <p:spTree>
@@ -11998,7 +12107,7 @@
 </p:sld>
 </file>
 
-<file path=ppt/slides/slide16.xml><?xml version="1.0" encoding="utf-8"?>
+<file path=ppt/slides/slide17.xml><?xml version="1.0" encoding="utf-8"?>
 <p:sld xmlns:a="http://schemas.openxmlformats.org/drawingml/2006/main" xmlns:r="http://schemas.openxmlformats.org/officeDocument/2006/relationships" xmlns:p="http://schemas.openxmlformats.org/presentationml/2006/main">
   <p:cSld>
     <p:spTree>
@@ -12136,7 +12245,7 @@
 </p:sld>
 </file>
 
-<file path=ppt/slides/slide17.xml><?xml version="1.0" encoding="utf-8"?>
+<file path=ppt/slides/slide18.xml><?xml version="1.0" encoding="utf-8"?>
 <p:sld xmlns:a="http://schemas.openxmlformats.org/drawingml/2006/main" xmlns:r="http://schemas.openxmlformats.org/officeDocument/2006/relationships" xmlns:p="http://schemas.openxmlformats.org/presentationml/2006/main">
   <p:cSld>
     <p:spTree>
@@ -12276,7 +12385,7 @@
 </p:sld>
 </file>
 
-<file path=ppt/slides/slide18.xml><?xml version="1.0" encoding="utf-8"?>
+<file path=ppt/slides/slide19.xml><?xml version="1.0" encoding="utf-8"?>
 <p:sld xmlns:a="http://schemas.openxmlformats.org/drawingml/2006/main" xmlns:r="http://schemas.openxmlformats.org/officeDocument/2006/relationships" xmlns:p="http://schemas.openxmlformats.org/presentationml/2006/main">
   <p:cSld>
     <p:spTree>
@@ -12558,129 +12667,6 @@
     <p:extLst>
       <p:ext uri="{BB962C8B-B14F-4D97-AF65-F5344CB8AC3E}">
         <p14:creationId xmlns:p14="http://schemas.microsoft.com/office/powerpoint/2010/main" val="2582021120"/>
-      </p:ext>
-    </p:extLst>
-  </p:cSld>
-  <p:clrMapOvr>
-    <a:masterClrMapping/>
-  </p:clrMapOvr>
-</p:sld>
-</file>
-
-<file path=ppt/slides/slide19.xml><?xml version="1.0" encoding="utf-8"?>
-<p:sld xmlns:a="http://schemas.openxmlformats.org/drawingml/2006/main" xmlns:r="http://schemas.openxmlformats.org/officeDocument/2006/relationships" xmlns:p="http://schemas.openxmlformats.org/presentationml/2006/main">
-  <p:cSld>
-    <p:spTree>
-      <p:nvGrpSpPr>
-        <p:cNvPr id="1" name=""/>
-        <p:cNvGrpSpPr/>
-        <p:nvPr/>
-      </p:nvGrpSpPr>
-      <p:grpSpPr>
-        <a:xfrm>
-          <a:off x="0" y="0"/>
-          <a:ext cx="0" cy="0"/>
-          <a:chOff x="0" y="0"/>
-          <a:chExt cx="0" cy="0"/>
-        </a:xfrm>
-      </p:grpSpPr>
-      <p:sp>
-        <p:nvSpPr>
-          <p:cNvPr id="2" name="Title 1">
-            <a:extLst>
-              <a:ext uri="{FF2B5EF4-FFF2-40B4-BE49-F238E27FC236}">
-                <a16:creationId xmlns:a16="http://schemas.microsoft.com/office/drawing/2014/main" id="{3FA2FBE7-F43D-C2BE-42F7-9B4DAC3D4C97}"/>
-              </a:ext>
-            </a:extLst>
-          </p:cNvPr>
-          <p:cNvSpPr>
-            <a:spLocks noGrp="1"/>
-          </p:cNvSpPr>
-          <p:nvPr>
-            <p:ph type="title"/>
-          </p:nvPr>
-        </p:nvSpPr>
-        <p:spPr/>
-        <p:txBody>
-          <a:bodyPr>
-            <a:normAutofit/>
-          </a:bodyPr>
-          <a:lstStyle/>
-          <a:p>
-            <a:r>
-              <a:rPr lang="en-US" sz="2000" b="1" dirty="0"/>
-              <a:t>                                                                             </a:t>
-            </a:r>
-            <a:r>
-              <a:rPr lang="en-US" sz="2000" b="1" dirty="0">
-                <a:solidFill>
-                  <a:schemeClr val="accent1"/>
-                </a:solidFill>
-                <a:latin typeface="Times New Roman" panose="02020603050405020304" pitchFamily="18" charset="0"/>
-                <a:cs typeface="Times New Roman" panose="02020603050405020304" pitchFamily="18" charset="0"/>
-              </a:rPr>
-              <a:t>Experience</a:t>
-            </a:r>
-            <a:endParaRPr lang="en-IN" sz="2000" b="1" dirty="0">
-              <a:solidFill>
-                <a:schemeClr val="accent1"/>
-              </a:solidFill>
-              <a:latin typeface="Times New Roman" panose="02020603050405020304" pitchFamily="18" charset="0"/>
-              <a:cs typeface="Times New Roman" panose="02020603050405020304" pitchFamily="18" charset="0"/>
-            </a:endParaRPr>
-          </a:p>
-        </p:txBody>
-      </p:sp>
-      <p:sp>
-        <p:nvSpPr>
-          <p:cNvPr id="5" name="TextBox 4">
-            <a:extLst>
-              <a:ext uri="{FF2B5EF4-FFF2-40B4-BE49-F238E27FC236}">
-                <a16:creationId xmlns:a16="http://schemas.microsoft.com/office/drawing/2014/main" id="{50C47E59-394D-A7E0-B0C9-18BFDF81641E}"/>
-              </a:ext>
-            </a:extLst>
-          </p:cNvPr>
-          <p:cNvSpPr txBox="1"/>
-          <p:nvPr/>
-        </p:nvSpPr>
-        <p:spPr>
-          <a:xfrm>
-            <a:off x="0" y="2088679"/>
-            <a:ext cx="12221029" cy="1754326"/>
-          </a:xfrm>
-          <a:prstGeom prst="rect">
-            <a:avLst/>
-          </a:prstGeom>
-          <a:noFill/>
-        </p:spPr>
-        <p:txBody>
-          <a:bodyPr wrap="square">
-            <a:spAutoFit/>
-          </a:bodyPr>
-          <a:lstStyle/>
-          <a:p>
-            <a:r>
-              <a:rPr lang="en-US" sz="1800" dirty="0"/>
-              <a:t>In this project analyzed rental housing trends across five major Indian cities by scraping and cleaning 1,200+ property listings from </a:t>
-            </a:r>
-            <a:r>
-              <a:rPr lang="en-US" sz="1800" dirty="0" err="1"/>
-              <a:t>MagicBricks</a:t>
-            </a:r>
-            <a:r>
-              <a:rPr lang="en-US" sz="1800" dirty="0"/>
-              <a:t> using Python. After transforming messy text data into structured numeric form, exploratory analysis revealed key insights like price–area correlation, city-wise rental differences, and furnishing premiums. Visualizations showed that BHK and bathroom count strongly influence rent. Overall, it demonstrated the full data science workflow from data collection to insight generation.</a:t>
-            </a:r>
-          </a:p>
-          <a:p>
-            <a:endParaRPr lang="en-GB" sz="1800" dirty="0"/>
-          </a:p>
-        </p:txBody>
-      </p:sp>
-    </p:spTree>
-    <p:extLst>
-      <p:ext uri="{BB962C8B-B14F-4D97-AF65-F5344CB8AC3E}">
-        <p14:creationId xmlns:p14="http://schemas.microsoft.com/office/powerpoint/2010/main" val="2884200202"/>
       </p:ext>
     </p:extLst>
   </p:cSld>
@@ -13102,6 +13088,129 @@
           <p:cNvPr id="2" name="Title 1">
             <a:extLst>
               <a:ext uri="{FF2B5EF4-FFF2-40B4-BE49-F238E27FC236}">
+                <a16:creationId xmlns:a16="http://schemas.microsoft.com/office/drawing/2014/main" id="{3FA2FBE7-F43D-C2BE-42F7-9B4DAC3D4C97}"/>
+              </a:ext>
+            </a:extLst>
+          </p:cNvPr>
+          <p:cNvSpPr>
+            <a:spLocks noGrp="1"/>
+          </p:cNvSpPr>
+          <p:nvPr>
+            <p:ph type="title"/>
+          </p:nvPr>
+        </p:nvSpPr>
+        <p:spPr/>
+        <p:txBody>
+          <a:bodyPr>
+            <a:normAutofit/>
+          </a:bodyPr>
+          <a:lstStyle/>
+          <a:p>
+            <a:r>
+              <a:rPr lang="en-US" sz="2000" b="1" dirty="0"/>
+              <a:t>                                                                             </a:t>
+            </a:r>
+            <a:r>
+              <a:rPr lang="en-US" sz="2000" b="1" dirty="0">
+                <a:solidFill>
+                  <a:schemeClr val="accent1"/>
+                </a:solidFill>
+                <a:latin typeface="Times New Roman" panose="02020603050405020304" pitchFamily="18" charset="0"/>
+                <a:cs typeface="Times New Roman" panose="02020603050405020304" pitchFamily="18" charset="0"/>
+              </a:rPr>
+              <a:t>Experience</a:t>
+            </a:r>
+            <a:endParaRPr lang="en-IN" sz="2000" b="1" dirty="0">
+              <a:solidFill>
+                <a:schemeClr val="accent1"/>
+              </a:solidFill>
+              <a:latin typeface="Times New Roman" panose="02020603050405020304" pitchFamily="18" charset="0"/>
+              <a:cs typeface="Times New Roman" panose="02020603050405020304" pitchFamily="18" charset="0"/>
+            </a:endParaRPr>
+          </a:p>
+        </p:txBody>
+      </p:sp>
+      <p:sp>
+        <p:nvSpPr>
+          <p:cNvPr id="5" name="TextBox 4">
+            <a:extLst>
+              <a:ext uri="{FF2B5EF4-FFF2-40B4-BE49-F238E27FC236}">
+                <a16:creationId xmlns:a16="http://schemas.microsoft.com/office/drawing/2014/main" id="{50C47E59-394D-A7E0-B0C9-18BFDF81641E}"/>
+              </a:ext>
+            </a:extLst>
+          </p:cNvPr>
+          <p:cNvSpPr txBox="1"/>
+          <p:nvPr/>
+        </p:nvSpPr>
+        <p:spPr>
+          <a:xfrm>
+            <a:off x="0" y="2088679"/>
+            <a:ext cx="12221029" cy="2585323"/>
+          </a:xfrm>
+          <a:prstGeom prst="rect">
+            <a:avLst/>
+          </a:prstGeom>
+          <a:noFill/>
+        </p:spPr>
+        <p:txBody>
+          <a:bodyPr wrap="square">
+            <a:spAutoFit/>
+          </a:bodyPr>
+          <a:lstStyle/>
+          <a:p>
+            <a:r>
+              <a:rPr lang="en-US" sz="2400" dirty="0"/>
+              <a:t>In this project analyzed rental housing trends across five major Indian cities by scraping and cleaning 1,200+ property listings from </a:t>
+            </a:r>
+            <a:r>
+              <a:rPr lang="en-US" sz="2400" dirty="0" err="1"/>
+              <a:t>MagicBricks</a:t>
+            </a:r>
+            <a:r>
+              <a:rPr lang="en-US" sz="2400" dirty="0"/>
+              <a:t> using Python. After transforming messy text data into structured numeric form, exploratory analysis revealed key insights like price–area correlation, city-wise rental differences, and furnishing premiums. Visualizations showed that BHK and bathroom count strongly influence rent. Overall, it demonstrated the full data science workflow from data collection to insight generation.</a:t>
+            </a:r>
+          </a:p>
+          <a:p>
+            <a:endParaRPr lang="en-GB" sz="1800" dirty="0"/>
+          </a:p>
+        </p:txBody>
+      </p:sp>
+    </p:spTree>
+    <p:extLst>
+      <p:ext uri="{BB962C8B-B14F-4D97-AF65-F5344CB8AC3E}">
+        <p14:creationId xmlns:p14="http://schemas.microsoft.com/office/powerpoint/2010/main" val="2884200202"/>
+      </p:ext>
+    </p:extLst>
+  </p:cSld>
+  <p:clrMapOvr>
+    <a:masterClrMapping/>
+  </p:clrMapOvr>
+</p:sld>
+</file>
+
+<file path=ppt/slides/slide21.xml><?xml version="1.0" encoding="utf-8"?>
+<p:sld xmlns:a="http://schemas.openxmlformats.org/drawingml/2006/main" xmlns:r="http://schemas.openxmlformats.org/officeDocument/2006/relationships" xmlns:p="http://schemas.openxmlformats.org/presentationml/2006/main">
+  <p:cSld>
+    <p:spTree>
+      <p:nvGrpSpPr>
+        <p:cNvPr id="1" name=""/>
+        <p:cNvGrpSpPr/>
+        <p:nvPr/>
+      </p:nvGrpSpPr>
+      <p:grpSpPr>
+        <a:xfrm>
+          <a:off x="0" y="0"/>
+          <a:ext cx="0" cy="0"/>
+          <a:chOff x="0" y="0"/>
+          <a:chExt cx="0" cy="0"/>
+        </a:xfrm>
+      </p:grpSpPr>
+      <p:sp>
+        <p:nvSpPr>
+          <p:cNvPr id="2" name="Title 1">
+            <a:extLst>
+              <a:ext uri="{FF2B5EF4-FFF2-40B4-BE49-F238E27FC236}">
                 <a16:creationId xmlns:a16="http://schemas.microsoft.com/office/drawing/2014/main" id="{14BEEA87-0024-49E1-64C8-CE80C098B0A6}"/>
               </a:ext>
             </a:extLst>
@@ -13158,7 +13267,7 @@
 </p:sld>
 </file>
 
-<file path=ppt/slides/slide21.xml><?xml version="1.0" encoding="utf-8"?>
+<file path=ppt/slides/slide22.xml><?xml version="1.0" encoding="utf-8"?>
 <p:sld xmlns:a="http://schemas.openxmlformats.org/drawingml/2006/main" xmlns:r="http://schemas.openxmlformats.org/officeDocument/2006/relationships" xmlns:p="http://schemas.openxmlformats.org/presentationml/2006/main">
   <p:cSld>
     <p:spTree>
@@ -13804,6 +13913,72 @@
   <p:cSld>
     <p:spTree>
       <p:nvGrpSpPr>
+        <p:cNvPr id="1" name="">
+          <a:extLst>
+            <a:ext uri="{FF2B5EF4-FFF2-40B4-BE49-F238E27FC236}">
+              <a16:creationId xmlns:a16="http://schemas.microsoft.com/office/drawing/2014/main" id="{85F530E1-2D3F-16E7-DD54-188861D6ABE3}"/>
+            </a:ext>
+          </a:extLst>
+        </p:cNvPr>
+        <p:cNvGrpSpPr/>
+        <p:nvPr/>
+      </p:nvGrpSpPr>
+      <p:grpSpPr>
+        <a:xfrm>
+          <a:off x="0" y="0"/>
+          <a:ext cx="0" cy="0"/>
+          <a:chOff x="0" y="0"/>
+          <a:chExt cx="0" cy="0"/>
+        </a:xfrm>
+      </p:grpSpPr>
+      <p:pic>
+        <p:nvPicPr>
+          <p:cNvPr id="5" name="Picture 4">
+            <a:extLst>
+              <a:ext uri="{FF2B5EF4-FFF2-40B4-BE49-F238E27FC236}">
+                <a16:creationId xmlns:a16="http://schemas.microsoft.com/office/drawing/2014/main" id="{42C884D6-49ED-96DA-5E81-D5752C693150}"/>
+              </a:ext>
+            </a:extLst>
+          </p:cNvPr>
+          <p:cNvPicPr>
+            <a:picLocks noChangeAspect="1"/>
+          </p:cNvPicPr>
+          <p:nvPr/>
+        </p:nvPicPr>
+        <p:blipFill>
+          <a:blip r:embed="rId2"/>
+          <a:stretch>
+            <a:fillRect/>
+          </a:stretch>
+        </p:blipFill>
+        <p:spPr>
+          <a:xfrm>
+            <a:off x="1163611" y="344774"/>
+            <a:ext cx="10378815" cy="5921115"/>
+          </a:xfrm>
+          <a:prstGeom prst="rect">
+            <a:avLst/>
+          </a:prstGeom>
+        </p:spPr>
+      </p:pic>
+    </p:spTree>
+    <p:extLst>
+      <p:ext uri="{BB962C8B-B14F-4D97-AF65-F5344CB8AC3E}">
+        <p14:creationId xmlns:p14="http://schemas.microsoft.com/office/powerpoint/2010/main" val="842180676"/>
+      </p:ext>
+    </p:extLst>
+  </p:cSld>
+  <p:clrMapOvr>
+    <a:masterClrMapping/>
+  </p:clrMapOvr>
+</p:sld>
+</file>
+
+<file path=ppt/slides/slide6.xml><?xml version="1.0" encoding="utf-8"?>
+<p:sld xmlns:a="http://schemas.openxmlformats.org/drawingml/2006/main" xmlns:r="http://schemas.openxmlformats.org/officeDocument/2006/relationships" xmlns:p="http://schemas.openxmlformats.org/presentationml/2006/main">
+  <p:cSld>
+    <p:spTree>
+      <p:nvGrpSpPr>
         <p:cNvPr id="1" name=""/>
         <p:cNvGrpSpPr/>
         <p:nvPr/>
@@ -13907,7 +14082,7 @@
 </p:sld>
 </file>
 
-<file path=ppt/slides/slide6.xml><?xml version="1.0" encoding="utf-8"?>
+<file path=ppt/slides/slide7.xml><?xml version="1.0" encoding="utf-8"?>
 <p:sld xmlns:a="http://schemas.openxmlformats.org/drawingml/2006/main" xmlns:r="http://schemas.openxmlformats.org/officeDocument/2006/relationships" xmlns:p="http://schemas.openxmlformats.org/presentationml/2006/main">
   <p:cSld>
     <p:spTree>
@@ -14022,7 +14197,7 @@
 </p:sld>
 </file>
 
-<file path=ppt/slides/slide7.xml><?xml version="1.0" encoding="utf-8"?>
+<file path=ppt/slides/slide8.xml><?xml version="1.0" encoding="utf-8"?>
 <p:sld xmlns:a="http://schemas.openxmlformats.org/drawingml/2006/main" xmlns:r="http://schemas.openxmlformats.org/officeDocument/2006/relationships" xmlns:p="http://schemas.openxmlformats.org/presentationml/2006/main">
   <p:cSld>
     <p:spTree>
@@ -14130,7 +14305,7 @@
 </p:sld>
 </file>
 
-<file path=ppt/slides/slide8.xml><?xml version="1.0" encoding="utf-8"?>
+<file path=ppt/slides/slide9.xml><?xml version="1.0" encoding="utf-8"?>
 <p:sld xmlns:a="http://schemas.openxmlformats.org/drawingml/2006/main" xmlns:r="http://schemas.openxmlformats.org/officeDocument/2006/relationships" xmlns:p="http://schemas.openxmlformats.org/presentationml/2006/main">
   <p:cSld>
     <p:spTree>
@@ -14263,114 +14438,6 @@
     <p:extLst>
       <p:ext uri="{BB962C8B-B14F-4D97-AF65-F5344CB8AC3E}">
         <p14:creationId xmlns:p14="http://schemas.microsoft.com/office/powerpoint/2010/main" val="3154108425"/>
-      </p:ext>
-    </p:extLst>
-  </p:cSld>
-  <p:clrMapOvr>
-    <a:masterClrMapping/>
-  </p:clrMapOvr>
-</p:sld>
-</file>
-
-<file path=ppt/slides/slide9.xml><?xml version="1.0" encoding="utf-8"?>
-<p:sld xmlns:a="http://schemas.openxmlformats.org/drawingml/2006/main" xmlns:r="http://schemas.openxmlformats.org/officeDocument/2006/relationships" xmlns:p="http://schemas.openxmlformats.org/presentationml/2006/main">
-  <p:cSld>
-    <p:spTree>
-      <p:nvGrpSpPr>
-        <p:cNvPr id="1" name=""/>
-        <p:cNvGrpSpPr/>
-        <p:nvPr/>
-      </p:nvGrpSpPr>
-      <p:grpSpPr>
-        <a:xfrm>
-          <a:off x="0" y="0"/>
-          <a:ext cx="0" cy="0"/>
-          <a:chOff x="0" y="0"/>
-          <a:chExt cx="0" cy="0"/>
-        </a:xfrm>
-      </p:grpSpPr>
-      <p:pic>
-        <p:nvPicPr>
-          <p:cNvPr id="4" name="Picture 3">
-            <a:extLst>
-              <a:ext uri="{FF2B5EF4-FFF2-40B4-BE49-F238E27FC236}">
-                <a16:creationId xmlns:a16="http://schemas.microsoft.com/office/drawing/2014/main" id="{92EF33CE-33B5-55EE-D839-F06634CC2E79}"/>
-              </a:ext>
-            </a:extLst>
-          </p:cNvPr>
-          <p:cNvPicPr>
-            <a:picLocks noChangeAspect="1"/>
-          </p:cNvPicPr>
-          <p:nvPr/>
-        </p:nvPicPr>
-        <p:blipFill>
-          <a:blip r:embed="rId2"/>
-          <a:stretch>
-            <a:fillRect/>
-          </a:stretch>
-        </p:blipFill>
-        <p:spPr>
-          <a:xfrm>
-            <a:off x="0" y="1181484"/>
-            <a:ext cx="12192000" cy="4495031"/>
-          </a:xfrm>
-          <a:prstGeom prst="rect">
-            <a:avLst/>
-          </a:prstGeom>
-        </p:spPr>
-      </p:pic>
-      <p:sp>
-        <p:nvSpPr>
-          <p:cNvPr id="6" name="TextBox 5">
-            <a:extLst>
-              <a:ext uri="{FF2B5EF4-FFF2-40B4-BE49-F238E27FC236}">
-                <a16:creationId xmlns:a16="http://schemas.microsoft.com/office/drawing/2014/main" id="{8FAFE32F-A5A1-6DBF-2190-651C056560F0}"/>
-              </a:ext>
-            </a:extLst>
-          </p:cNvPr>
-          <p:cNvSpPr txBox="1"/>
-          <p:nvPr/>
-        </p:nvSpPr>
-        <p:spPr>
-          <a:xfrm>
-            <a:off x="0" y="338912"/>
-            <a:ext cx="12192000" cy="355418"/>
-          </a:xfrm>
-          <a:prstGeom prst="rect">
-            <a:avLst/>
-          </a:prstGeom>
-          <a:noFill/>
-        </p:spPr>
-        <p:txBody>
-          <a:bodyPr wrap="square">
-            <a:spAutoFit/>
-          </a:bodyPr>
-          <a:lstStyle/>
-          <a:p>
-            <a:pPr algn="ctr">
-              <a:lnSpc>
-                <a:spcPts val="1425"/>
-              </a:lnSpc>
-              <a:buNone/>
-            </a:pPr>
-            <a:r>
-              <a:rPr lang="en-GB" sz="4400" kern="1200" dirty="0">
-                <a:solidFill>
-                  <a:schemeClr val="tx1"/>
-                </a:solidFill>
-                <a:latin typeface="+mj-lt"/>
-                <a:ea typeface="+mj-ea"/>
-                <a:cs typeface="+mj-cs"/>
-              </a:rPr>
-              <a:t>Furnishing Status Analysis</a:t>
-            </a:r>
-          </a:p>
-        </p:txBody>
-      </p:sp>
-    </p:spTree>
-    <p:extLst>
-      <p:ext uri="{BB962C8B-B14F-4D97-AF65-F5344CB8AC3E}">
-        <p14:creationId xmlns:p14="http://schemas.microsoft.com/office/powerpoint/2010/main" val="372715865"/>
       </p:ext>
     </p:extLst>
   </p:cSld>

</xml_diff>